<commit_message>
Add HCMUTE logo to every slide and fill in the GitHub link
Co-Authored-By: Claude Opus 5.5 <noreply@anthropic.com>
Claude-Session: https://claude.ai/code/session_01ViY4qA4PYMu7ja7Fwb2Msy
</commit_message>
<xml_diff>
--- a/FinalReport/Group6_Platform_Driver_Presentation.pptx
+++ b/FinalReport/Group6_Platform_Driver_Presentation.pptx
@@ -1910,6 +1910,61 @@
           </a:p>
         </p:txBody>
       </p:sp>
+      <p:sp>
+        <p:nvSpPr>
+          <p:cNvPr id="900" name="HCMUTE logo background"/>
+          <p:cNvSpPr/>
+          <p:nvPr userDrawn="1"/>
+        </p:nvSpPr>
+        <p:spPr>
+          <a:xfrm>
+            <a:off x="8119872" y="137160"/>
+            <a:ext cx="566928" cy="667817"/>
+          </a:xfrm>
+          <a:prstGeom prst="roundRect">
+            <a:avLst>
+              <a:gd name="adj" fmla="val 12000"/>
+            </a:avLst>
+          </a:prstGeom>
+          <a:solidFill>
+            <a:srgbClr val="FFFFFF"/>
+          </a:solidFill>
+          <a:ln>
+            <a:noFill/>
+          </a:ln>
+        </p:spPr>
+        <p:txBody>
+          <a:bodyPr/>
+          <a:lstStyle/>
+          <a:p>
+            <a:endParaRPr lang="en-US"/>
+          </a:p>
+        </p:txBody>
+      </p:sp>
+      <p:pic>
+        <p:nvPicPr>
+          <p:cNvPr id="901" name="HCMUTE logo" descr="HCMUTE logo"/>
+          <p:cNvPicPr>
+            <a:picLocks noChangeAspect="1"/>
+          </p:cNvPicPr>
+          <p:nvPr userDrawn="1"/>
+        </p:nvPicPr>
+        <p:blipFill>
+          <a:blip r:embed="rIdLogo"/>
+          <a:stretch>
+            <a:fillRect/>
+          </a:stretch>
+        </p:blipFill>
+        <p:spPr>
+          <a:xfrm>
+            <a:off x="8193024" y="201168"/>
+            <a:ext cx="420624" cy="539801"/>
+          </a:xfrm>
+          <a:prstGeom prst="rect">
+            <a:avLst/>
+          </a:prstGeom>
+        </p:spPr>
+      </p:pic>
     </p:spTree>
   </p:cSld>
   <p:clrMapOvr>
@@ -2065,6 +2120,30 @@
           </a:p>
         </p:txBody>
       </p:sp>
+      <p:pic>
+        <p:nvPicPr>
+          <p:cNvPr id="901" name="HCMUTE logo" descr="HCMUTE logo"/>
+          <p:cNvPicPr>
+            <a:picLocks noChangeAspect="1"/>
+          </p:cNvPicPr>
+          <p:nvPr userDrawn="1"/>
+        </p:nvPicPr>
+        <p:blipFill>
+          <a:blip r:embed="rIdLogo"/>
+          <a:stretch>
+            <a:fillRect/>
+          </a:stretch>
+        </p:blipFill>
+        <p:spPr>
+          <a:xfrm>
+            <a:off x="8321040" y="201168"/>
+            <a:ext cx="365760" cy="469392"/>
+          </a:xfrm>
+          <a:prstGeom prst="rect">
+            <a:avLst/>
+          </a:prstGeom>
+        </p:spPr>
+      </p:pic>
     </p:spTree>
   </p:cSld>
   <p:clrMapOvr>
@@ -2184,6 +2263,61 @@
           </a:p>
         </p:txBody>
       </p:sp>
+      <p:sp>
+        <p:nvSpPr>
+          <p:cNvPr id="900" name="HCMUTE logo background"/>
+          <p:cNvSpPr/>
+          <p:nvPr userDrawn="1"/>
+        </p:nvSpPr>
+        <p:spPr>
+          <a:xfrm>
+            <a:off x="8119872" y="137160"/>
+            <a:ext cx="566928" cy="667817"/>
+          </a:xfrm>
+          <a:prstGeom prst="roundRect">
+            <a:avLst>
+              <a:gd name="adj" fmla="val 12000"/>
+            </a:avLst>
+          </a:prstGeom>
+          <a:solidFill>
+            <a:srgbClr val="FFFFFF"/>
+          </a:solidFill>
+          <a:ln>
+            <a:noFill/>
+          </a:ln>
+        </p:spPr>
+        <p:txBody>
+          <a:bodyPr/>
+          <a:lstStyle/>
+          <a:p>
+            <a:endParaRPr lang="en-US"/>
+          </a:p>
+        </p:txBody>
+      </p:sp>
+      <p:pic>
+        <p:nvPicPr>
+          <p:cNvPr id="901" name="HCMUTE logo" descr="HCMUTE logo"/>
+          <p:cNvPicPr>
+            <a:picLocks noChangeAspect="1"/>
+          </p:cNvPicPr>
+          <p:nvPr userDrawn="1"/>
+        </p:nvPicPr>
+        <p:blipFill>
+          <a:blip r:embed="rIdLogo"/>
+          <a:stretch>
+            <a:fillRect/>
+          </a:stretch>
+        </p:blipFill>
+        <p:spPr>
+          <a:xfrm>
+            <a:off x="8193024" y="201168"/>
+            <a:ext cx="420624" cy="539801"/>
+          </a:xfrm>
+          <a:prstGeom prst="rect">
+            <a:avLst/>
+          </a:prstGeom>
+        </p:spPr>
+      </p:pic>
     </p:spTree>
   </p:cSld>
   <p:clrMapOvr>
@@ -6717,7 +6851,15 @@
                   <a:schemeClr val="accent6"/>
                 </a:solidFill>
               </a:rPr>
-              <a:t>GitHub: https://github.com/……………………………………………</a:t>
+              <a:t>GitHub: </a:t>
+            </a:r>
+            <a:r>
+              <a:rPr lang="en-US" sz="1600" b="1" dirty="0">
+                <a:solidFill>
+                  <a:schemeClr val="bg1"/>
+                </a:solidFill>
+              </a:rPr>
+              <a:t>https://github.com/Tun-afk/Embedded-System</a:t>
             </a:r>
             <a:endParaRPr lang="en-US" sz="1600" dirty="0"/>
           </a:p>

</xml_diff>

<commit_message>
Slides: member table and GitHub link on the title slide
</commit_message>
<xml_diff>
--- a/FinalReport/Group6_Platform_Driver_Presentation.pptx
+++ b/FinalReport/Group6_Platform_Driver_Presentation.pptx
@@ -2681,8 +2681,8 @@
         </p:nvSpPr>
         <p:spPr>
           <a:xfrm>
-            <a:off x="458260" y="642271"/>
-            <a:ext cx="5416760" cy="509423"/>
+            <a:off x="457200" y="411480"/>
+            <a:ext cx="5413248" cy="274320"/>
           </a:xfrm>
           <a:prstGeom prst="rect">
             <a:avLst/>
@@ -2721,8 +2721,8 @@
         </p:nvSpPr>
         <p:spPr>
           <a:xfrm>
-            <a:off x="457200" y="1234440"/>
-            <a:ext cx="5120640" cy="1371600"/>
+            <a:off x="457200" y="777240"/>
+            <a:ext cx="5120640" cy="1143000"/>
           </a:xfrm>
           <a:prstGeom prst="rect">
             <a:avLst/>
@@ -2761,8 +2761,8 @@
         </p:nvSpPr>
         <p:spPr>
           <a:xfrm>
-            <a:off x="457200" y="2651760"/>
-            <a:ext cx="5120640" cy="822960"/>
+            <a:off x="457200" y="1965960"/>
+            <a:ext cx="5120640" cy="502920"/>
           </a:xfrm>
           <a:prstGeom prst="rect">
             <a:avLst/>
@@ -2778,27 +2778,602 @@
               <a:buNone/>
             </a:pPr>
             <a:r>
-              <a:rPr lang="en-US" sz="1600" dirty="0">
+              <a:rPr lang="en-US" sz="1400" dirty="0">
                 <a:solidFill>
                   <a:schemeClr val="accent6"/>
                 </a:solidFill>
               </a:rPr>
               <a:t>Platform drivers with Device Tree on the Raspberry Pi Zero W: Timer, PWM and DS1307 RTC</a:t>
             </a:r>
-            <a:endParaRPr lang="en-US" sz="1600" dirty="0"/>
-          </a:p>
-        </p:txBody>
-      </p:sp>
-      <p:sp>
-        <p:nvSpPr>
-          <p:cNvPr id="5" name="Text 3"/>
+            <a:endParaRPr lang="en-US" sz="1400" dirty="0"/>
+          </a:p>
+        </p:txBody>
+      </p:sp>
+      <p:sp>
+        <p:nvSpPr>
+          <p:cNvPr id="5" name="Group label"/>
           <p:cNvSpPr txBox="1"/>
           <p:nvPr/>
         </p:nvSpPr>
         <p:spPr>
           <a:xfrm>
-            <a:off x="457200" y="3703320"/>
-            <a:ext cx="5303520" cy="914400"/>
+            <a:off x="457200" y="2560320"/>
+            <a:ext cx="4846320" cy="228600"/>
+          </a:xfrm>
+          <a:prstGeom prst="rect">
+            <a:avLst/>
+          </a:prstGeom>
+          <a:noFill/>
+          <a:ln/>
+        </p:spPr>
+        <p:txBody>
+          <a:bodyPr wrap="square" lIns="0" tIns="0" rIns="0" bIns="0" rtlCol="0" anchor="t"/>
+          <a:lstStyle/>
+          <a:p>
+            <a:pPr marL="0" indent="0">
+              <a:spcAft>
+                <a:spcPts val="0"/>
+              </a:spcAft>
+              <a:buNone/>
+            </a:pPr>
+            <a:r>
+              <a:rPr lang="en-US" sz="1400" b="1" dirty="0">
+                <a:solidFill>
+                  <a:schemeClr val="bg1"/>
+                </a:solidFill>
+              </a:rPr>
+              <a:t>Group 6</a:t>
+            </a:r>
+          </a:p>
+        </p:txBody>
+      </p:sp>
+      <p:graphicFrame>
+        <p:nvGraphicFramePr>
+          <p:cNvPr id="7" name="Member table"/>
+          <p:cNvGraphicFramePr>
+            <a:graphicFrameLocks noGrp="1"/>
+          </p:cNvGraphicFramePr>
+          <p:nvPr/>
+        </p:nvGraphicFramePr>
+        <p:xfrm>
+          <a:off x="457200" y="2834640"/>
+          <a:ext cx="4846320" cy="987552"/>
+        </p:xfrm>
+        <a:graphic>
+          <a:graphicData uri="http://schemas.openxmlformats.org/drawingml/2006/table">
+            <a:tbl>
+              <a:tblPr firstRow="1" bandRow="1"/>
+              <a:tblGrid>
+                <a:gridCol w="548640"/>
+                <a:gridCol w="2743200"/>
+                <a:gridCol w="1554480"/>
+              </a:tblGrid>
+              <a:tr h="246888">
+                <a:tc>
+                  <a:txBody>
+                    <a:bodyPr/>
+                    <a:lstStyle/>
+                    <a:p>
+                      <a:pPr algn="ctr"/>
+                      <a:r>
+                        <a:rPr lang="vi-VN" sz="1200" b="1" dirty="0">
+                          <a:solidFill>
+                            <a:schemeClr val="bg1"/>
+                          </a:solidFill>
+                        </a:rPr>
+                        <a:t>No.</a:t>
+                      </a:r>
+                    </a:p>
+                  </a:txBody>
+                  <a:tcPr marL="73152" marR="73152" marT="27432" marB="27432" anchor="ctr">
+                    <a:lnL w="6350">
+                      <a:solidFill>
+                        <a:srgbClr val="5B6E80"/>
+                      </a:solidFill>
+                    </a:lnL>
+                    <a:lnR w="6350">
+                      <a:solidFill>
+                        <a:srgbClr val="5B6E80"/>
+                      </a:solidFill>
+                    </a:lnR>
+                    <a:lnT w="6350">
+                      <a:solidFill>
+                        <a:srgbClr val="5B6E80"/>
+                      </a:solidFill>
+                    </a:lnT>
+                    <a:lnB w="6350">
+                      <a:solidFill>
+                        <a:srgbClr val="5B6E80"/>
+                      </a:solidFill>
+                    </a:lnB>
+                    <a:solidFill>
+                      <a:srgbClr val="C51A4A"/>
+                    </a:solidFill>
+                  </a:tcPr>
+                </a:tc>
+                <a:tc>
+                  <a:txBody>
+                    <a:bodyPr/>
+                    <a:lstStyle/>
+                    <a:p>
+                      <a:pPr algn="l"/>
+                      <a:r>
+                        <a:rPr lang="vi-VN" sz="1200" b="1" dirty="0">
+                          <a:solidFill>
+                            <a:schemeClr val="bg1"/>
+                          </a:solidFill>
+                        </a:rPr>
+                        <a:t>Full name</a:t>
+                      </a:r>
+                    </a:p>
+                  </a:txBody>
+                  <a:tcPr marL="73152" marR="73152" marT="27432" marB="27432" anchor="ctr">
+                    <a:lnL w="6350">
+                      <a:solidFill>
+                        <a:srgbClr val="5B6E80"/>
+                      </a:solidFill>
+                    </a:lnL>
+                    <a:lnR w="6350">
+                      <a:solidFill>
+                        <a:srgbClr val="5B6E80"/>
+                      </a:solidFill>
+                    </a:lnR>
+                    <a:lnT w="6350">
+                      <a:solidFill>
+                        <a:srgbClr val="5B6E80"/>
+                      </a:solidFill>
+                    </a:lnT>
+                    <a:lnB w="6350">
+                      <a:solidFill>
+                        <a:srgbClr val="5B6E80"/>
+                      </a:solidFill>
+                    </a:lnB>
+                    <a:solidFill>
+                      <a:srgbClr val="C51A4A"/>
+                    </a:solidFill>
+                  </a:tcPr>
+                </a:tc>
+                <a:tc>
+                  <a:txBody>
+                    <a:bodyPr/>
+                    <a:lstStyle/>
+                    <a:p>
+                      <a:pPr algn="ctr"/>
+                      <a:r>
+                        <a:rPr lang="vi-VN" sz="1200" b="1" dirty="0">
+                          <a:solidFill>
+                            <a:schemeClr val="bg1"/>
+                          </a:solidFill>
+                        </a:rPr>
+                        <a:t>Student ID</a:t>
+                      </a:r>
+                    </a:p>
+                  </a:txBody>
+                  <a:tcPr marL="73152" marR="73152" marT="27432" marB="27432" anchor="ctr">
+                    <a:lnL w="6350">
+                      <a:solidFill>
+                        <a:srgbClr val="5B6E80"/>
+                      </a:solidFill>
+                    </a:lnL>
+                    <a:lnR w="6350">
+                      <a:solidFill>
+                        <a:srgbClr val="5B6E80"/>
+                      </a:solidFill>
+                    </a:lnR>
+                    <a:lnT w="6350">
+                      <a:solidFill>
+                        <a:srgbClr val="5B6E80"/>
+                      </a:solidFill>
+                    </a:lnT>
+                    <a:lnB w="6350">
+                      <a:solidFill>
+                        <a:srgbClr val="5B6E80"/>
+                      </a:solidFill>
+                    </a:lnB>
+                    <a:solidFill>
+                      <a:srgbClr val="C51A4A"/>
+                    </a:solidFill>
+                  </a:tcPr>
+                </a:tc>
+              </a:tr>
+              <a:tr h="246888">
+                <a:tc>
+                  <a:txBody>
+                    <a:bodyPr/>
+                    <a:lstStyle/>
+                    <a:p>
+                      <a:pPr algn="ctr"/>
+                      <a:r>
+                        <a:rPr lang="vi-VN" sz="1200" dirty="0">
+                          <a:solidFill>
+                            <a:schemeClr val="bg1"/>
+                          </a:solidFill>
+                        </a:rPr>
+                        <a:t>1</a:t>
+                      </a:r>
+                    </a:p>
+                  </a:txBody>
+                  <a:tcPr marL="73152" marR="73152" marT="27432" marB="27432" anchor="ctr">
+                    <a:lnL w="6350">
+                      <a:solidFill>
+                        <a:srgbClr val="5B6E80"/>
+                      </a:solidFill>
+                    </a:lnL>
+                    <a:lnR w="6350">
+                      <a:solidFill>
+                        <a:srgbClr val="5B6E80"/>
+                      </a:solidFill>
+                    </a:lnR>
+                    <a:lnT w="6350">
+                      <a:solidFill>
+                        <a:srgbClr val="5B6E80"/>
+                      </a:solidFill>
+                    </a:lnT>
+                    <a:lnB w="6350">
+                      <a:solidFill>
+                        <a:srgbClr val="5B6E80"/>
+                      </a:solidFill>
+                    </a:lnB>
+                    <a:solidFill>
+                      <a:srgbClr val="2B3D4E"/>
+                    </a:solidFill>
+                  </a:tcPr>
+                </a:tc>
+                <a:tc>
+                  <a:txBody>
+                    <a:bodyPr/>
+                    <a:lstStyle/>
+                    <a:p>
+                      <a:pPr algn="l"/>
+                      <a:r>
+                        <a:rPr lang="vi-VN" sz="1200" dirty="0">
+                          <a:solidFill>
+                            <a:schemeClr val="bg1"/>
+                          </a:solidFill>
+                        </a:rPr>
+                        <a:t>Võ Trần Đăng Khoa</a:t>
+                      </a:r>
+                    </a:p>
+                  </a:txBody>
+                  <a:tcPr marL="73152" marR="73152" marT="27432" marB="27432" anchor="ctr">
+                    <a:lnL w="6350">
+                      <a:solidFill>
+                        <a:srgbClr val="5B6E80"/>
+                      </a:solidFill>
+                    </a:lnL>
+                    <a:lnR w="6350">
+                      <a:solidFill>
+                        <a:srgbClr val="5B6E80"/>
+                      </a:solidFill>
+                    </a:lnR>
+                    <a:lnT w="6350">
+                      <a:solidFill>
+                        <a:srgbClr val="5B6E80"/>
+                      </a:solidFill>
+                    </a:lnT>
+                    <a:lnB w="6350">
+                      <a:solidFill>
+                        <a:srgbClr val="5B6E80"/>
+                      </a:solidFill>
+                    </a:lnB>
+                    <a:solidFill>
+                      <a:srgbClr val="2B3D4E"/>
+                    </a:solidFill>
+                  </a:tcPr>
+                </a:tc>
+                <a:tc>
+                  <a:txBody>
+                    <a:bodyPr/>
+                    <a:lstStyle/>
+                    <a:p>
+                      <a:pPr algn="ctr"/>
+                      <a:r>
+                        <a:rPr lang="vi-VN" sz="1200" dirty="0">
+                          <a:solidFill>
+                            <a:schemeClr val="bg1"/>
+                          </a:solidFill>
+                        </a:rPr>
+                        <a:t>24119051</a:t>
+                      </a:r>
+                    </a:p>
+                  </a:txBody>
+                  <a:tcPr marL="73152" marR="73152" marT="27432" marB="27432" anchor="ctr">
+                    <a:lnL w="6350">
+                      <a:solidFill>
+                        <a:srgbClr val="5B6E80"/>
+                      </a:solidFill>
+                    </a:lnL>
+                    <a:lnR w="6350">
+                      <a:solidFill>
+                        <a:srgbClr val="5B6E80"/>
+                      </a:solidFill>
+                    </a:lnR>
+                    <a:lnT w="6350">
+                      <a:solidFill>
+                        <a:srgbClr val="5B6E80"/>
+                      </a:solidFill>
+                    </a:lnT>
+                    <a:lnB w="6350">
+                      <a:solidFill>
+                        <a:srgbClr val="5B6E80"/>
+                      </a:solidFill>
+                    </a:lnB>
+                    <a:solidFill>
+                      <a:srgbClr val="2B3D4E"/>
+                    </a:solidFill>
+                  </a:tcPr>
+                </a:tc>
+              </a:tr>
+              <a:tr h="246888">
+                <a:tc>
+                  <a:txBody>
+                    <a:bodyPr/>
+                    <a:lstStyle/>
+                    <a:p>
+                      <a:pPr algn="ctr"/>
+                      <a:r>
+                        <a:rPr lang="vi-VN" sz="1200" dirty="0">
+                          <a:solidFill>
+                            <a:schemeClr val="bg1"/>
+                          </a:solidFill>
+                        </a:rPr>
+                        <a:t>2</a:t>
+                      </a:r>
+                    </a:p>
+                  </a:txBody>
+                  <a:tcPr marL="73152" marR="73152" marT="27432" marB="27432" anchor="ctr">
+                    <a:lnL w="6350">
+                      <a:solidFill>
+                        <a:srgbClr val="5B6E80"/>
+                      </a:solidFill>
+                    </a:lnL>
+                    <a:lnR w="6350">
+                      <a:solidFill>
+                        <a:srgbClr val="5B6E80"/>
+                      </a:solidFill>
+                    </a:lnR>
+                    <a:lnT w="6350">
+                      <a:solidFill>
+                        <a:srgbClr val="5B6E80"/>
+                      </a:solidFill>
+                    </a:lnT>
+                    <a:lnB w="6350">
+                      <a:solidFill>
+                        <a:srgbClr val="5B6E80"/>
+                      </a:solidFill>
+                    </a:lnB>
+                    <a:solidFill>
+                      <a:srgbClr val="34485B"/>
+                    </a:solidFill>
+                  </a:tcPr>
+                </a:tc>
+                <a:tc>
+                  <a:txBody>
+                    <a:bodyPr/>
+                    <a:lstStyle/>
+                    <a:p>
+                      <a:pPr algn="l"/>
+                      <a:r>
+                        <a:rPr lang="vi-VN" sz="1200" dirty="0">
+                          <a:solidFill>
+                            <a:schemeClr val="bg1"/>
+                          </a:solidFill>
+                        </a:rPr>
+                        <a:t>Phạm Trần Huy Hoàng</a:t>
+                      </a:r>
+                    </a:p>
+                  </a:txBody>
+                  <a:tcPr marL="73152" marR="73152" marT="27432" marB="27432" anchor="ctr">
+                    <a:lnL w="6350">
+                      <a:solidFill>
+                        <a:srgbClr val="5B6E80"/>
+                      </a:solidFill>
+                    </a:lnL>
+                    <a:lnR w="6350">
+                      <a:solidFill>
+                        <a:srgbClr val="5B6E80"/>
+                      </a:solidFill>
+                    </a:lnR>
+                    <a:lnT w="6350">
+                      <a:solidFill>
+                        <a:srgbClr val="5B6E80"/>
+                      </a:solidFill>
+                    </a:lnT>
+                    <a:lnB w="6350">
+                      <a:solidFill>
+                        <a:srgbClr val="5B6E80"/>
+                      </a:solidFill>
+                    </a:lnB>
+                    <a:solidFill>
+                      <a:srgbClr val="34485B"/>
+                    </a:solidFill>
+                  </a:tcPr>
+                </a:tc>
+                <a:tc>
+                  <a:txBody>
+                    <a:bodyPr/>
+                    <a:lstStyle/>
+                    <a:p>
+                      <a:pPr algn="ctr"/>
+                      <a:r>
+                        <a:rPr lang="vi-VN" sz="1200" dirty="0">
+                          <a:solidFill>
+                            <a:schemeClr val="bg1"/>
+                          </a:solidFill>
+                        </a:rPr>
+                        <a:t>24119039</a:t>
+                      </a:r>
+                    </a:p>
+                  </a:txBody>
+                  <a:tcPr marL="73152" marR="73152" marT="27432" marB="27432" anchor="ctr">
+                    <a:lnL w="6350">
+                      <a:solidFill>
+                        <a:srgbClr val="5B6E80"/>
+                      </a:solidFill>
+                    </a:lnL>
+                    <a:lnR w="6350">
+                      <a:solidFill>
+                        <a:srgbClr val="5B6E80"/>
+                      </a:solidFill>
+                    </a:lnR>
+                    <a:lnT w="6350">
+                      <a:solidFill>
+                        <a:srgbClr val="5B6E80"/>
+                      </a:solidFill>
+                    </a:lnT>
+                    <a:lnB w="6350">
+                      <a:solidFill>
+                        <a:srgbClr val="5B6E80"/>
+                      </a:solidFill>
+                    </a:lnB>
+                    <a:solidFill>
+                      <a:srgbClr val="34485B"/>
+                    </a:solidFill>
+                  </a:tcPr>
+                </a:tc>
+              </a:tr>
+              <a:tr h="246888">
+                <a:tc>
+                  <a:txBody>
+                    <a:bodyPr/>
+                    <a:lstStyle/>
+                    <a:p>
+                      <a:pPr algn="ctr"/>
+                      <a:r>
+                        <a:rPr lang="vi-VN" sz="1200" dirty="0">
+                          <a:solidFill>
+                            <a:schemeClr val="bg1"/>
+                          </a:solidFill>
+                        </a:rPr>
+                        <a:t>3</a:t>
+                      </a:r>
+                    </a:p>
+                  </a:txBody>
+                  <a:tcPr marL="73152" marR="73152" marT="27432" marB="27432" anchor="ctr">
+                    <a:lnL w="6350">
+                      <a:solidFill>
+                        <a:srgbClr val="5B6E80"/>
+                      </a:solidFill>
+                    </a:lnL>
+                    <a:lnR w="6350">
+                      <a:solidFill>
+                        <a:srgbClr val="5B6E80"/>
+                      </a:solidFill>
+                    </a:lnR>
+                    <a:lnT w="6350">
+                      <a:solidFill>
+                        <a:srgbClr val="5B6E80"/>
+                      </a:solidFill>
+                    </a:lnT>
+                    <a:lnB w="6350">
+                      <a:solidFill>
+                        <a:srgbClr val="5B6E80"/>
+                      </a:solidFill>
+                    </a:lnB>
+                    <a:solidFill>
+                      <a:srgbClr val="2B3D4E"/>
+                    </a:solidFill>
+                  </a:tcPr>
+                </a:tc>
+                <a:tc>
+                  <a:txBody>
+                    <a:bodyPr/>
+                    <a:lstStyle/>
+                    <a:p>
+                      <a:pPr algn="l"/>
+                      <a:r>
+                        <a:rPr lang="vi-VN" sz="1200" dirty="0">
+                          <a:solidFill>
+                            <a:schemeClr val="bg1"/>
+                          </a:solidFill>
+                        </a:rPr>
+                        <a:t>Huỳnh Anh Tuấn</a:t>
+                      </a:r>
+                    </a:p>
+                  </a:txBody>
+                  <a:tcPr marL="73152" marR="73152" marT="27432" marB="27432" anchor="ctr">
+                    <a:lnL w="6350">
+                      <a:solidFill>
+                        <a:srgbClr val="5B6E80"/>
+                      </a:solidFill>
+                    </a:lnL>
+                    <a:lnR w="6350">
+                      <a:solidFill>
+                        <a:srgbClr val="5B6E80"/>
+                      </a:solidFill>
+                    </a:lnR>
+                    <a:lnT w="6350">
+                      <a:solidFill>
+                        <a:srgbClr val="5B6E80"/>
+                      </a:solidFill>
+                    </a:lnT>
+                    <a:lnB w="6350">
+                      <a:solidFill>
+                        <a:srgbClr val="5B6E80"/>
+                      </a:solidFill>
+                    </a:lnB>
+                    <a:solidFill>
+                      <a:srgbClr val="2B3D4E"/>
+                    </a:solidFill>
+                  </a:tcPr>
+                </a:tc>
+                <a:tc>
+                  <a:txBody>
+                    <a:bodyPr/>
+                    <a:lstStyle/>
+                    <a:p>
+                      <a:pPr algn="ctr"/>
+                      <a:r>
+                        <a:rPr lang="vi-VN" sz="1200" dirty="0">
+                          <a:solidFill>
+                            <a:schemeClr val="bg1"/>
+                          </a:solidFill>
+                        </a:rPr>
+                        <a:t>24119096</a:t>
+                      </a:r>
+                    </a:p>
+                  </a:txBody>
+                  <a:tcPr marL="73152" marR="73152" marT="27432" marB="27432" anchor="ctr">
+                    <a:lnL w="6350">
+                      <a:solidFill>
+                        <a:srgbClr val="5B6E80"/>
+                      </a:solidFill>
+                    </a:lnL>
+                    <a:lnR w="6350">
+                      <a:solidFill>
+                        <a:srgbClr val="5B6E80"/>
+                      </a:solidFill>
+                    </a:lnR>
+                    <a:lnT w="6350">
+                      <a:solidFill>
+                        <a:srgbClr val="5B6E80"/>
+                      </a:solidFill>
+                    </a:lnT>
+                    <a:lnB w="6350">
+                      <a:solidFill>
+                        <a:srgbClr val="5B6E80"/>
+                      </a:solidFill>
+                    </a:lnB>
+                    <a:solidFill>
+                      <a:srgbClr val="2B3D4E"/>
+                    </a:solidFill>
+                  </a:tcPr>
+                </a:tc>
+              </a:tr>
+            </a:tbl>
+          </a:graphicData>
+        </a:graphic>
+      </p:graphicFrame>
+      <p:sp>
+        <p:nvSpPr>
+          <p:cNvPr id="8" name="Lecturer and GitHub"/>
+          <p:cNvSpPr txBox="1"/>
+          <p:nvPr/>
+        </p:nvSpPr>
+        <p:spPr>
+          <a:xfrm>
+            <a:off x="457200" y="3931920"/>
+            <a:ext cx="5394960" cy="566928"/>
           </a:xfrm>
           <a:prstGeom prst="rect">
             <a:avLst/>
@@ -2817,48 +3392,44 @@
               <a:buNone/>
             </a:pPr>
             <a:r>
-              <a:rPr lang="en-US" sz="1400" b="1" dirty="0">
-                <a:solidFill>
-                  <a:schemeClr val="bg1"/>
-                </a:solidFill>
-              </a:rPr>
-              <a:t>Group 6</a:t>
-            </a:r>
-            <a:endParaRPr lang="en-US" sz="1400" dirty="0"/>
+              <a:rPr lang="en-US" sz="1300" dirty="0">
+                <a:solidFill>
+                  <a:schemeClr val="accent6"/>
+                </a:solidFill>
+              </a:rPr>
+              <a:t>Lecturer: Huỳnh Hoàng Hà</a:t>
+            </a:r>
           </a:p>
           <a:p>
             <a:pPr marL="0" indent="0">
               <a:spcAft>
-                <a:spcPts val="400"/>
+                <a:spcPts val="0"/>
               </a:spcAft>
               <a:buNone/>
             </a:pPr>
             <a:r>
-              <a:rPr lang="en-US" sz="1400" dirty="0">
+              <a:rPr lang="en-US" sz="1300" b="1" dirty="0">
                 <a:solidFill>
                   <a:schemeClr val="bg1"/>
                 </a:solidFill>
               </a:rPr>
-              <a:t>Võ Trần Đăng Khoa  ·  Phạm Trần Huy Hoàng  ·  Huỳnh Anh Tuấn</a:t>
-            </a:r>
-            <a:endParaRPr lang="en-US" sz="1400" dirty="0"/>
-          </a:p>
-          <a:p>
-            <a:pPr marL="0" indent="0">
-              <a:spcAft>
-                <a:spcPts val="400"/>
-              </a:spcAft>
-              <a:buNone/>
-            </a:pPr>
-            <a:r>
-              <a:rPr lang="en-US" sz="1400" dirty="0">
-                <a:solidFill>
-                  <a:schemeClr val="accent6"/>
-                </a:solidFill>
-              </a:rPr>
-              <a:t>Lecturer: Huỳnh Hoàng Hà</a:t>
-            </a:r>
-            <a:endParaRPr lang="en-US" sz="1400" dirty="0"/>
+              <a:t>GitHub: </a:t>
+            </a:r>
+            <a:r>
+              <a:rPr lang="en-US" sz="1300" b="1" u="sng" dirty="0">
+                <a:solidFill>
+                  <a:schemeClr val="bg1"/>
+                </a:solidFill>
+                <a:hlinkClick r:id="rIdGh">
+                  <a:extLst>
+                    <a:ext uri="{A12FA001-AC4F-418D-AE19-62706E023703}">
+                      <ahyp:hlinkClr xmlns:ahyp="http://schemas.microsoft.com/office/drawing/2018/hyperlinkcolor" val="tx"/>
+                    </a:ext>
+                  </a:extLst>
+                </a:hlinkClick>
+              </a:rPr>
+              <a:t>https://github.com/Tun-afk/Embedded-System</a:t>
+            </a:r>
           </a:p>
         </p:txBody>
       </p:sp>

</xml_diff>